<commit_message>
Update PPTX and PDF: simple English, speaking cues, emojis, AI Tools Hub, Gemini voice bot, clean justification
</commit_message>
<xml_diff>
--- a/VidyaUday_Official_Review_Presentation.pptx
+++ b/VidyaUday_Official_Review_Presentation.pptx
@@ -5116,7 +5116,7 @@
               </a:defRPr>
             </a:pPr>
             <a:r>
-              <a:t>1. Student Access</a:t>
+              <a:t>1. Student Visits VidyaUday</a:t>
             </a:r>
           </a:p>
           <a:p>
@@ -5129,7 +5129,7 @@
               </a:defRPr>
             </a:pPr>
             <a:r>
-              <a:t>Visits lightweight, zero-login web platform on mobile/desktop; chooses English or Telugu.</a:t>
+              <a:t>Opens lightweight web platform on any mobile browser with zero login, no app installation, and zero ads.</a:t>
             </a:r>
           </a:p>
         </p:txBody>
@@ -5200,7 +5200,7 @@
               </a:defRPr>
             </a:pPr>
             <a:r>
-              <a:t>Selects Career Roadmaps, Scholarship Finder, SCERT Books, AI Hub, or Scam Buster.</a:t>
+              <a:t>Chooses from 🤖 AI Tools, 🗺️ Career Roadmaps, 🏆 Scholarships, 📚 SCERT Books, 💻 Coding, or 🛡️ Scam Buster.</a:t>
             </a:r>
           </a:p>
         </p:txBody>
@@ -5258,7 +5258,7 @@
               </a:defRPr>
             </a:pPr>
             <a:r>
-              <a:t>3. Interactive Input</a:t>
+              <a:t>3. Student Interacts or Asks Uday</a:t>
             </a:r>
           </a:p>
           <a:p>
@@ -5271,7 +5271,7 @@
               </a:defRPr>
             </a:pPr>
             <a:r>
-              <a:t>Inputs simple criteria: class level, stream of interest, family income, and state (AP/TS).</a:t>
+              <a:t>Inputs class stream or asks questions directly to Uday the Owl AI assistant via voice or text in Telugu or English.</a:t>
             </a:r>
           </a:p>
         </p:txBody>
@@ -5329,7 +5329,7 @@
               </a:defRPr>
             </a:pPr>
             <a:r>
-              <a:t>4. Logic Execution</a:t>
+              <a:t>4. Instant Client-Side Processing</a:t>
             </a:r>
           </a:p>
           <a:p>
@@ -5342,7 +5342,7 @@
               </a:defRPr>
             </a:pPr>
             <a:r>
-              <a:t>Client-side JS rule engine evaluates eligibility matrix, filters schemes, and renders results.</a:t>
+              <a:t>JavaScript rule engine evaluates eligibility matrix, filters curated schemes, and renders personalized results.</a:t>
             </a:r>
           </a:p>
         </p:txBody>
@@ -5400,7 +5400,7 @@
               </a:defRPr>
             </a:pPr>
             <a:r>
-              <a:t>5. Empowered Action</a:t>
+              <a:t>5. Empowered Student Action</a:t>
             </a:r>
           </a:p>
           <a:p>
@@ -5413,7 +5413,7 @@
               </a:defRPr>
             </a:pPr>
             <a:r>
-              <a:t>Student accesses official application links, downloads offline guides, and applies safely.</a:t>
+              <a:t>Student accesses official apply links, copies AI prompts for homework, or downloads offline study packs.</a:t>
             </a:r>
           </a:p>
         </p:txBody>
@@ -5886,7 +5886,7 @@
               </a:defRPr>
             </a:pPr>
             <a:r>
-              <a:t>Layer 1: User Interface &amp; Presentation Layer</a:t>
+              <a:t>Layer 1: Presentation &amp; User Interface Layer</a:t>
             </a:r>
           </a:p>
           <a:p>
@@ -5899,7 +5899,7 @@
               </a:defRPr>
             </a:pPr>
             <a:r>
-              <a:t>Responsive Mobile-First UI (HTML5/CSS3)  |  Bilingual Switcher (English/Telugu)  |  Web Speech Voice Assistant  |  High-Contrast Typography</a:t>
+              <a:t>Responsive Mobile-First UI (HTML5/CSS3)  •  Bilingual Switcher (English/Telugu)  •  Web Speech Voice Engine  •  Clean Accessibility</a:t>
             </a:r>
           </a:p>
         </p:txBody>
@@ -5957,7 +5957,7 @@
               </a:defRPr>
             </a:pPr>
             <a:r>
-              <a:t>Layer 2: Core Feature &amp; Application Layer</a:t>
+              <a:t>Layer 2: Core Feature Modules</a:t>
             </a:r>
           </a:p>
           <a:p>
@@ -5970,7 +5970,7 @@
               </a:defRPr>
             </a:pPr>
             <a:r>
-              <a:t>Interactive Career Roadmaps  |  AP/TS Dual Scholarship Matcher  |  Scheme Comparison Matrix  |  SCERT Books Hub  |  AI Prompts  |  Scam Buster</a:t>
+              <a:t>🤖 AI Tools Hub  •  🦉 Uday Owl Chatbot  •  🗺️ Career Roadmaps  •  🏆 Scholarship Finder  •  📚 SCERT Textbooks  •  🛡️ Scam Buster</a:t>
             </a:r>
           </a:p>
         </p:txBody>
@@ -6028,7 +6028,7 @@
               </a:defRPr>
             </a:pPr>
             <a:r>
-              <a:t>Layer 3: Client-Side Logic &amp; Offline Storage</a:t>
+              <a:t>Layer 3: AI &amp; Client-Side Logic Engine</a:t>
             </a:r>
           </a:p>
           <a:p>
@@ -6041,7 +6041,7 @@
               </a:defRPr>
             </a:pPr>
             <a:r>
-              <a:t>JavaScript Dynamic Filter Engines  |  Eligibility Decision Tree Matrix  |  Browser LocalStorage  |  Offline Resource Pack Generator</a:t>
+              <a:t>Google Gemini 1.5 Flash API  •  Web Speech Voice Synthesis  •  JavaScript Decision Tree Matrix  •  LocalStorage Offline Cache</a:t>
             </a:r>
           </a:p>
         </p:txBody>
@@ -6099,7 +6099,7 @@
               </a:defRPr>
             </a:pPr>
             <a:r>
-              <a:t>Layer 4: External Data &amp; Verification Layer</a:t>
+              <a:t>Layer 4: Data &amp; Verification Layer</a:t>
             </a:r>
           </a:p>
           <a:p>
@@ -6112,7 +6112,7 @@
               </a:defRPr>
             </a:pPr>
             <a:r>
-              <a:t>Official AP Social Welfare (JVD) Rules  |  Telangana ePASS (CGG) Data  |  National Scholarship Portal (NSP)  |  AP/TS SCERT Curriculum</a:t>
+              <a:t>Curated Student AI Prompts  •  Official Welfare Gazettes (JVD &amp; ePASS)  •  National Scholarship Portal  •  SCERT Curriculum Data</a:t>
             </a:r>
           </a:p>
         </p:txBody>
@@ -6385,7 +6385,7 @@
               </a:defRPr>
             </a:pPr>
             <a:r>
-              <a:t>Six comprehensive modules built and verified on the live platform</a:t>
+              <a:t>Comprehensive features built and verified on the live VidyaUday platform</a:t>
             </a:r>
           </a:p>
         </p:txBody>
@@ -6582,7 +6582,7 @@
               </a:defRPr>
             </a:pPr>
             <a:r>
-              <a:t>•  1. Interactive Career Roadmap Explorer: Year-by-year academic and career path mapping after 10th and 12th covering MPC, BiPC, CEC, MEC, Polytechnic, and ITI with degree outcomes and entrance exams.</a:t>
+              <a:t>🤖  AI Tools &amp; Prompt Templates: Curated 10+ free AI tools (ChatGPT, Gemini, Canva, Gamma) with 1-click copyable prompts for maths problem-solving, essay outlines, and Telugu translation.</a:t>
             </a:r>
           </a:p>
           <a:p>
@@ -6598,7 +6598,7 @@
               </a:defRPr>
             </a:pPr>
             <a:r>
-              <a:t>•  2. AP/TS Dual Scholarship Eligibility Engine: Interactive 30-second checker evaluating state, caste, annual income, and class level against AP JVD, TS ePASS, NSP Post-Matric, NMMS, and AICTE Pragati schemes.</a:t>
+              <a:t>🦉  Uday the Owl AI Assistant: Trilingual chatbot powered by Google Gemini 1.5 Flash API with Web Speech voice input and voice reading in English, Telugu, and Hindi.</a:t>
             </a:r>
           </a:p>
           <a:p>
@@ -6614,7 +6614,7 @@
               </a:defRPr>
             </a:pPr>
             <a:r>
-              <a:t>•  3. Scheme Comparison &amp; Application Matrix: Side-by-side comparative table analyzing benefits, eligibility caps, deadline calendars, and direct verified official application portals.</a:t>
+              <a:t>🗺️  Interactive Career Roadmaps: Step-by-step career path mapping after 10th and 12th covering MPC, BiPC, CEC, MEC, Polytechnic, and ITI with degree outcomes and real salary growth timelines.</a:t>
             </a:r>
           </a:p>
           <a:p>
@@ -6630,7 +6630,7 @@
               </a:defRPr>
             </a:pPr>
             <a:r>
-              <a:t>•  4. Curated Student AI Study Prompts: Categorized, 1-click copyable prompts for Google Gemini and ChatGPT assisting with homework, math solutions, essay outlining, and English-Telugu translation.</a:t>
+              <a:t>🏆  Scholarship Checker &amp; Matrix: 30-second eligibility checker evaluating caste, income, and class against Central and State schemes, complete with a side-by-side comparison matrix.</a:t>
             </a:r>
           </a:p>
           <a:p>
@@ -6646,7 +6646,7 @@
               </a:defRPr>
             </a:pPr>
             <a:r>
-              <a:t>•  5. Digital Literacy &amp; Cyber Scam Buster: 3-mode hub featuring student digital safety checklists, a 30-second readiness self-assessment quiz, and practical guides to detect phishing and fake scholarship traps.</a:t>
+              <a:t>📚  Learning Hub &amp; SCERT Books: 1-click access to digitized state SCERT textbooks, DIKSHA, SWAYAM, and NPTEL free certification platforms.</a:t>
             </a:r>
           </a:p>
           <a:p>
@@ -6662,7 +6662,7 @@
               </a:defRPr>
             </a:pPr>
             <a:r>
-              <a:t>•  6. Universal Accessibility &amp; Offline Packs: 1-click downloadable printable study and scholarship guides, coupled with bilingual speech synthesis for vernacular auditory learners.</a:t>
+              <a:t>🛡️  Digital Literacy &amp; Scam Buster: 3-mode hub featuring student digital safety checklists, a 30-second readiness self-assessment quiz, and guides to detect fake scholarship scams.</a:t>
             </a:r>
           </a:p>
         </p:txBody>
@@ -7770,7 +7770,7 @@
               </a:defRPr>
             </a:pPr>
             <a:r>
-              <a:t>Social Impact on Rural Student Communities</a:t>
+              <a:t>Social &amp; Educational Impact on Rural Students</a:t>
             </a:r>
           </a:p>
           <a:p>
@@ -7786,7 +7786,7 @@
               </a:defRPr>
             </a:pPr>
             <a:r>
-              <a:t>•  Democratized Career Guidance: Equips rural students with structured, multi-stream career visibility, breaking generational cycles of choosing courses purely based on local peer pressure.</a:t>
+              <a:t>🎓  Informed Career Choices: Breaks peer pressure by helping rural students explore diploma, vocational, and non-traditional careers with clear degree outcomes.</a:t>
             </a:r>
           </a:p>
           <a:p>
@@ -7802,7 +7802,7 @@
               </a:defRPr>
             </a:pPr>
             <a:r>
-              <a:t>•  Elimination of Exploitative Intermediaries: Empowers students and parents to understand scholarship eligibility and application procedures directly, eliminating cyber café commission fees (₹200–₹500/application).</a:t>
+              <a:t>💸  Eliminates Cyber Café Charges: Empowers students to discover schemes and apply directly without paying ₹200–₹500 in service charges for each form.</a:t>
             </a:r>
           </a:p>
           <a:p>
@@ -7818,7 +7818,7 @@
               </a:defRPr>
             </a:pPr>
             <a:r>
-              <a:t>•  Digital Empowerment &amp; Cyber Safety: Promotes responsible online hygiene, digital self-confidence, and proactive scam defense among vulnerable first-generation internet users.</a:t>
+              <a:t>🛡️  Builds Cyber Hygiene &amp; Safety: Trains first-generation internet users to avoid online scam traps, protect OTPs, and report cyber fraud to helpline 1930.</a:t>
             </a:r>
           </a:p>
           <a:p>
@@ -7853,7 +7853,7 @@
               </a:defRPr>
             </a:pPr>
             <a:r>
-              <a:t>•  Zero-Barrier Universal Access: High-speed, responsive performance that loads in under 1.5 seconds on 3G/4G rural networks with zero battery or data overhead.</a:t>
+              <a:t>⚡  Sub-1.5s Load Time on 3G: High-speed, responsive single-page architecture optimized for low-cost smartphones and rural mobile networks.</a:t>
             </a:r>
           </a:p>
           <a:p>
@@ -7869,7 +7869,7 @@
               </a:defRPr>
             </a:pPr>
             <a:r>
-              <a:t>•  Privacy-First Architecture: 100% client-side data evaluation with zero database storage, ensuring complete compliance with student digital privacy standards.</a:t>
+              <a:t>🤖  Real AI &amp; Voice Integration: Integrates Google Gemini 1.5 Flash API and Web Speech API into a zero-login, privacy-first web application.</a:t>
             </a:r>
           </a:p>
         </p:txBody>
@@ -8339,7 +8339,7 @@
               </a:defRPr>
             </a:pPr>
             <a:r>
-              <a:t>•  State-Specific Rule Discrepancies: Challenge: AP and Telangana maintain divergent scholarship eligibility criteria, caste classifications, and portal architectures. Solution: Engineered a unified, state-aware JSON decision matrix that dynamically maps student inputs to state-specific statutory guidelines.</a:t>
+              <a:t>🤖  Making AI Accessible to School Students: Challenge: Rural students do not know how to prompt AI tools like ChatGPT or Gemini effectively. Solution: Created 1-click copyable prompt cards tailored specifically for homework help, maths problem-solving, and vernacular translation.</a:t>
             </a:r>
           </a:p>
           <a:p>
@@ -8355,7 +8355,7 @@
               </a:defRPr>
             </a:pPr>
             <a:r>
-              <a:t>•  Rural Bandwidth &amp; Device Constraints: Challenge: Target rural students access the web on low-spec smartphones over unstable 3G/4G mobile connections. Solution: Replaced resource-heavy frameworks with pure lightweight JavaScript, CSS grid layouts, SVG icons, and printable offline download packs.</a:t>
+              <a:t>⚖️  Handling Diverse Government Scholarship Rules: Challenge: Central and State scholarship schemes maintain divergent eligibility rules, income caps, and portal structures. Solution: Engineered a unified, state-aware JSON decision rule engine that dynamically evaluates student profiles in seconds.</a:t>
             </a:r>
           </a:p>
           <a:p>
@@ -8371,7 +8371,7 @@
               </a:defRPr>
             </a:pPr>
             <a:r>
-              <a:t>•  Vernacular Language &amp; Terminology Translation: Challenge: Complex government circulars and academic guidance are unintelligible to rural students in English. Solution: Authored authentic bilingual Telugu translations paired with browser-native Web Speech API voice synthesis for auditory accessibility.</a:t>
+              <a:t>📶  Rural Internet &amp; Low-Spec Device Constraints: Challenge: Rural students predominantly browse on basic smartphones with intermittent mobile connectivity. Solution: Replaced resource-heavy frameworks with pure lightweight JavaScript, clean CSS, SVG icons, and printable offline download packs.</a:t>
             </a:r>
           </a:p>
         </p:txBody>
@@ -8644,7 +8644,7 @@
               </a:defRPr>
             </a:pPr>
             <a:r>
-              <a:t>What VidyaUday proves — and what it means for every rural student in AP &amp; TS</a:t>
+              <a:t>What VidyaUday proves — and what it means for every rural student</a:t>
             </a:r>
           </a:p>
         </p:txBody>
@@ -8844,7 +8844,7 @@
               </a:defRPr>
             </a:pPr>
             <a:r>
-              <a:t>•  Successfully engineered and deployed VidyaUday as a 100% free, production-ready community educational empowerment platform.</a:t>
+              <a:t>🏆  Built a Production-Ready Platform: Successfully deployed VidyaUday as a 100% free, all-in-one educational guidance platform for rural students.</a:t>
             </a:r>
           </a:p>
           <a:p>
@@ -8860,7 +8860,7 @@
               </a:defRPr>
             </a:pPr>
             <a:r>
-              <a:t>•  Centralized diverse educational tracks, statutory AP/TS scholarships, digitized SCERT textbooks, and student AI prompts into a unified single-page portal.</a:t>
+              <a:t>🤖  United AI Tools, Roadmaps &amp; Scholarships: Centralized curated AI tools, interactive career streams, government scholarships, and SCERT textbooks into one clean web portal.</a:t>
             </a:r>
           </a:p>
           <a:p>
@@ -8876,7 +8876,7 @@
               </a:defRPr>
             </a:pPr>
             <a:r>
-              <a:t>•  Integrated practical digital literacy drills and cyber scam defense guides to protect students from predatory online coaching and scholarship fraud.</a:t>
+              <a:t>🦉  Integrated Conversational AI &amp; Speech: Integrated Google Gemini 1.5 Flash API and Web Speech voice technology so language is never a barrier.</a:t>
             </a:r>
           </a:p>
           <a:p>
@@ -8911,7 +8911,7 @@
               </a:defRPr>
             </a:pPr>
             <a:r>
-              <a:t>•  VidyaUday demonstrates that accessible, thoughtful technology can bridge the urban-rural educational divide. By placing high-quality guidance, scholarship access, and digital literacy directly into students' hands at zero cost, we empower rural youth to make confident, informed choices for their future.</a:t>
+              <a:t>🌟  VidyaUday demonstrates that accessible, thoughtful technology can bridge the rural education divide. By placing high-quality guidance, scholarship access, and digital literacy directly into students' hands at zero cost, we empower rural youth to make confident, informed choices for their future.</a:t>
             </a:r>
           </a:p>
         </p:txBody>
@@ -9381,7 +9381,7 @@
               </a:defRPr>
             </a:pPr>
             <a:r>
-              <a:t>•  Progressive Web App (PWA) Offline Engine: Implement complete service worker caching to allow full offline operation on village smartphones even when network connectivity drops completely.</a:t>
+              <a:t>📲  Progressive Web App (PWA) Offline Engine: Implement service-worker caching to allow students to access career roadmaps, guides, and prompts with zero internet connectivity.</a:t>
             </a:r>
           </a:p>
           <a:p>
@@ -9397,7 +9397,7 @@
               </a:defRPr>
             </a:pPr>
             <a:r>
-              <a:t>•  Automated WhatsApp / Telegram Community Bot: Develop an automated vernacular bot sending automated scholarship deadline reminders, entrance exam alerts, and career FAQs directly to students' family phones.</a:t>
+              <a:t>🤖  Automated WhatsApp &amp; Telegram Alert Bot: Develop an automated vernacular bot sending scholarship deadline reminders, entrance exam alerts, and career FAQs directly to family phones.</a:t>
             </a:r>
           </a:p>
           <a:p>
@@ -9413,7 +9413,7 @@
               </a:defRPr>
             </a:pPr>
             <a:r>
-              <a:t>•  College Student Mentorship Network: Establish a digital volunteer mentorship bridge connecting senior engineering students from MVGR College with rural school students for 1-on-1 career guidance.</a:t>
+              <a:t>🤝  College Student Mentorship Network: Establish a digital volunteer bridge connecting senior engineering students from MVGR College with rural school students for 1-on-1 career guidance.</a:t>
             </a:r>
           </a:p>
           <a:p>
@@ -9429,7 +9429,7 @@
               </a:defRPr>
             </a:pPr>
             <a:r>
-              <a:t>•  Native Ultra-Lightweight Android APK: Package the platform into a standalone 2MB Android application distributed freely through village schools, Grama Sachivalayams, and local libraries.</a:t>
+              <a:t>📦  Native Ultra-Lightweight Android APK: Package the platform into a standalone 2MB Android application distributed freely through village schools, Grama Sachivalayams, and local libraries.</a:t>
             </a:r>
           </a:p>
         </p:txBody>
@@ -9899,7 +9899,7 @@
               </a:defRPr>
             </a:pPr>
             <a:r>
-              <a:t>[1] Ministry of Human Resource Development (MHRD), "National Education Policy 2020," Government of India, New Delhi, 2020.</a:t>
+              <a:t>🏛️  [1] National Education Policy (NEP 2020), Ministry of Education, Government of India, New Delhi.</a:t>
             </a:r>
           </a:p>
           <a:p>
@@ -9915,7 +9915,7 @@
               </a:defRPr>
             </a:pPr>
             <a:r>
-              <a:t>[2] National Scholarship Portal (NSP), Ministry of Electronics and Information Technology, Government of India. Available: https://scholarships.gov.in</a:t>
+              <a:t>🌐  [2] National Scholarship Portal (NSP), Ministry of Electronics &amp; IT, Govt of India: https://scholarships.gov.in</a:t>
             </a:r>
           </a:p>
           <a:p>
@@ -9931,7 +9931,7 @@
               </a:defRPr>
             </a:pPr>
             <a:r>
-              <a:t>[3] Andhra Pradesh State Social Welfare Department, "G.O. Ms. No. 77 &amp; 115 — Jagananna Vidya Deevena &amp; Vasathi Deevena Regulations," Amaravati, AP.</a:t>
+              <a:t>📑  [3] State Social Welfare Department Gazettes &amp; ePASS Electronic Scholarship System: https://telanganaepass.cgg.gov.in</a:t>
             </a:r>
           </a:p>
           <a:p>
@@ -9947,7 +9947,7 @@
               </a:defRPr>
             </a:pPr>
             <a:r>
-              <a:t>[4] Centre for Good Governance (CGG), "Telangana Electronic Payment and Application System of Scholarships (ePASS)," Govt of Telangana. Available: https://telanganaepass.cgg.gov.in</a:t>
+              <a:t>🤖  [4] Google Gemini API Documentation, Google AI for Developers, Generative Language API, 2024.</a:t>
             </a:r>
           </a:p>
           <a:p>
@@ -9963,7 +9963,7 @@
               </a:defRPr>
             </a:pPr>
             <a:r>
-              <a:t>[5] Pratham Education Foundation, "Annual Status of Education Report (ASER) 2023: Beyond Basics," New Delhi, 2024.</a:t>
+              <a:t>📊  [5] Pratham Education Foundation, "Annual Status of Education Report (ASER): Beyond Basics," New Delhi.</a:t>
             </a:r>
           </a:p>
           <a:p>
@@ -9979,7 +9979,7 @@
               </a:defRPr>
             </a:pPr>
             <a:r>
-              <a:t>[6] National Cyber Crime Reporting Portal &amp; Indian Cyber Crime Coordination Centre (I4C), Ministry of Home Affairs, Govt of India. Available: https://cybercrime.gov.in</a:t>
+              <a:t>🚨  [6] National Cyber Crime Reporting Portal (Helpline 1930), Indian Cyber Crime Coordination Centre (I4C), MHA: https://cybercrime.gov.in</a:t>
             </a:r>
           </a:p>
         </p:txBody>
@@ -10452,7 +10452,7 @@
               </a:defRPr>
             </a:pPr>
             <a:r>
-              <a:t>•  Rural 10th and Intermediate students in Andhra Pradesh and Telangana face a severe guidance deficit, remaining largely unaware of higher education pathways, statutory government scholarships, and free AI learning tools.</a:t>
+              <a:t>🌾  Rural Student Guidance Gap: Lakhs of rural 10th and Intermediate students complete board exams without proper career guidance, unaware of free AI learning tools and government financial aid.</a:t>
             </a:r>
           </a:p>
           <a:p>
@@ -10468,7 +10468,7 @@
               </a:defRPr>
             </a:pPr>
             <a:r>
-              <a:t>•  Essential academic information remains fragmented across dense government gazettes, English-dominant portals, and aggressive commercial coaching apps charging predatory fees.</a:t>
+              <a:t>💸  Commercial Coaching Traps: Private apps charge ₹20,000–₹50,000 for guidance, while 100% free government resources, scholarships, and digitized textbooks remain undiscovered.</a:t>
             </a:r>
           </a:p>
           <a:p>
@@ -10487,7 +10487,7 @@
               </a:defRPr>
             </a:pPr>
             <a:r>
-              <a:t>Our Solution</a:t>
+              <a:t>Our Solution (VidyaUday)</a:t>
             </a:r>
           </a:p>
           <a:p>
@@ -10503,7 +10503,7 @@
               </a:defRPr>
             </a:pPr>
             <a:r>
-              <a:t>•  VidyaUday provides a 100% free, mobile-optimized, bilingual web platform requiring zero login, no app installation, and zero personal data collection.</a:t>
+              <a:t>🌐  All-in-One Free Web Platform: A mobile-friendly portal requiring zero login, no app installation, and zero personal data collection.</a:t>
             </a:r>
           </a:p>
           <a:p>
@@ -10519,7 +10519,7 @@
               </a:defRPr>
             </a:pPr>
             <a:r>
-              <a:t>•  Integrates dual-state scholarship eligibility matching, interactive career roadmaps (MPC, BiPC, CEC, Polytechnic, ITI), SCERT digital textbooks, and a dedicated Digital Literacy &amp; Cyber Scam Buster Hub.</a:t>
+              <a:t>🤖  Seven Comprehensive Modules: Brings together 10+ free AI tools with copyable prompts, career roadmaps, a 30-sec scholarship checker, SCERT textbooks, coding guides, cyber scam defense, and Uday the Owl AI chatbot.</a:t>
             </a:r>
           </a:p>
           <a:p>
@@ -10554,7 +10554,7 @@
               </a:defRPr>
             </a:pPr>
             <a:r>
-              <a:t>•  Eliminates dependency on expensive cyber cafés, maximizes statutory scholarship claim rates across rural districts, and empowers first-generation learners with confident digital safety.</a:t>
+              <a:t>🎓  Direct Student Empowerment: Saves cyber café application fees, helps rural students claim statutory scholarships, and builds foundational AI and digital literacy.</a:t>
             </a:r>
           </a:p>
         </p:txBody>
@@ -11011,7 +11011,7 @@
               </a:defRPr>
             </a:pPr>
             <a:r>
-              <a:t>The Growing Rural Challenge</a:t>
+              <a:t>The Rural Student Challenge</a:t>
             </a:r>
           </a:p>
           <a:p>
@@ -11027,7 +11027,7 @@
               </a:defRPr>
             </a:pPr>
             <a:r>
-              <a:t>•  Over 12 lakh students complete 10th and Intermediate board exams annually across Andhra Pradesh and Telangana, yet rural students lack structured career mentoring and make life-defining decisions blindly.</a:t>
+              <a:t>👥  Blind Decision Making: Lakhs of rural students pass 10th and Intermediate every year, choosing groups and colleges purely based on peer pressure or limited family knowledge.</a:t>
             </a:r>
           </a:p>
           <a:p>
@@ -11043,7 +11043,7 @@
               </a:defRPr>
             </a:pPr>
             <a:r>
-              <a:t>•  Commercial coaching institutes exploit this vacuum by charging exorbitant fees (₹25,000–₹50,000), leaving economically disadvantaged rural students behind.</a:t>
+              <a:t>💸  Exploitation by Intermediaries: Students pay ₹200–₹500 to private cyber cafés just to fill basic forms, often missing critical scholarship deadlines due to procedural complexity.</a:t>
             </a:r>
           </a:p>
           <a:p>
@@ -11078,23 +11078,7 @@
               </a:defRPr>
             </a:pPr>
             <a:r>
-              <a:t>•  While excellent government welfare schemes and digital resources exist, they are scattered across fragmented portals in complex English without vernacular guidance.</a:t>
-            </a:r>
-          </a:p>
-          <a:p>
-            <a:pPr algn="just">
-              <a:spcAft>
-                <a:spcPts val="400"/>
-              </a:spcAft>
-              <a:defRPr sz="2100">
-                <a:solidFill>
-                  <a:srgbClr val="1E293B"/>
-                </a:solidFill>
-                <a:latin typeface="Times New Roman"/>
-              </a:defRPr>
-            </a:pPr>
-            <a:r>
-              <a:t>•  Rural students frequently miss application deadlines for fully funded government scholarships due to procedural obscurity and lack of digital awareness.</a:t>
+              <a:t>🔍  Scattered Official Portals: Genuine welfare schemes and study materials exist, but they are buried across multiple English-only government websites without vernacular guidance.</a:t>
             </a:r>
           </a:p>
           <a:p>
@@ -11113,7 +11097,7 @@
               </a:defRPr>
             </a:pPr>
             <a:r>
-              <a:t>Our Platform: VidyaUday</a:t>
+              <a:t>Our Platform: VidyaUday (Seven Essential Modules)</a:t>
             </a:r>
           </a:p>
           <a:p>
@@ -11129,7 +11113,7 @@
               </a:defRPr>
             </a:pPr>
             <a:r>
-              <a:t>•  VidyaUday bridges this digital divide as a lightweight, bilingual (English &amp; Telugu) portal uniting career paths, scholarship finders, AI study prompts, and cyber safety tools under one roof.</a:t>
+              <a:t>🦉  Unified Educational Portal: Combines 🤖 AI Tools, 🗺️ Career Roadmaps, 🏆 Scholarships, 📚 SCERT Books, 💻 Coding Practice, 🛡️ Cyber Scam Buster, and 🦉 Uday AI Chatbot under one roof.</a:t>
             </a:r>
           </a:p>
         </p:txBody>
@@ -11599,7 +11583,7 @@
               </a:defRPr>
             </a:pPr>
             <a:r>
-              <a:t>Lakhs of rural 10th and Intermediate students in Andhra Pradesh and Telangana face a severe guidance deficit, making critical educational and career decisions blindly without awareness of statutory government scholarships, digital learning platforms, or modern technology tools. Fragmented government notifications, dense English-only web portals, and aggressive commercial coaching traps systematically disenfranchise first-generation rural learners.</a:t>
+              <a:t>Lakhs of rural 10th and Intermediate students face a severe guidance gap, making life-defining educational choices without awareness of emerging AI study tools, diverse career streams, or statutory government scholarships. Fragmented government portals, English-dominant websites, and aggressive commercial coaching fees systematically leave first-generation learners behind.</a:t>
             </a:r>
           </a:p>
           <a:p>
@@ -11618,7 +11602,7 @@
               </a:defRPr>
             </a:pPr>
             <a:r>
-              <a:t>Key Pain Points Identified in Rural Field Survey</a:t>
+              <a:t>Real Findings from Our Rural Student Survey</a:t>
             </a:r>
           </a:p>
           <a:p>
@@ -11634,7 +11618,7 @@
               </a:defRPr>
             </a:pPr>
             <a:r>
-              <a:t>•  Information Asymmetry: 74.2% of surveyed rural students are unaware of viable career alternatives beyond traditional MPC/BiPC streams.</a:t>
+              <a:t>❓  74.2% Lack Career Awareness: Unaware of viable diploma, vocational, or technical career options beyond traditional MPC/BiPC streams.</a:t>
             </a:r>
           </a:p>
           <a:p>
@@ -11650,7 +11634,7 @@
               </a:defRPr>
             </a:pPr>
             <a:r>
-              <a:t>•  Unclaimed Welfare Aid: Over ₹50,000 per student in statutory government scholarships remains unclaimed annually due to lack of deadline visibility.</a:t>
+              <a:t>💸  ₹50,000+ Aid Missed Annually: Deserving students miss out on government fee reimbursements simply due to lack of deadline visibility and application support.</a:t>
             </a:r>
           </a:p>
           <a:p>
@@ -11666,7 +11650,7 @@
               </a:defRPr>
             </a:pPr>
             <a:r>
-              <a:t>•  The Digital Divide: 81.5% of students have never utilized free educational AI tools or cyber hygiene practices for academic advancement.</a:t>
+              <a:t>🤖  81.5% Never Used AI Tools: Have never utilized free AI tools like ChatGPT or Gemini to help with homework, maths problem-solving, or language learning.</a:t>
             </a:r>
           </a:p>
         </p:txBody>
@@ -12136,7 +12120,7 @@
               </a:defRPr>
             </a:pPr>
             <a:r>
-              <a:t>•  Bilingual Career Guidance: Provide structured, year-by-year career path navigators for 10th and Intermediate streams (MPC, BiPC, CEC, MEC, Polytechnic, ITI) in English and Telugu.</a:t>
+              <a:t>🤖  Democratize Educational AI: Introduce rural students to 10+ free AI tools (ChatGPT, Gemini, Canva, Gamma) with 1-click copyable prompts for homework, maths, and essays.</a:t>
             </a:r>
           </a:p>
           <a:p>
@@ -12152,7 +12136,7 @@
               </a:defRPr>
             </a:pPr>
             <a:r>
-              <a:t>•  Centralized Scholarship Discovery: Streamline statutory Central and State schemes (AP JVD, TS ePASS, NMMS, Pragati) with instant dual-state eligibility matching and deadline tracking.</a:t>
+              <a:t>🗺️  Provide Clear Career Roadmaps: Deliver year-by-year paths after 10th &amp; Intermediate (MPC, BiPC, CEC, MEC, Polytechnic, ITI) with verified salary growth timelines.</a:t>
             </a:r>
           </a:p>
           <a:p>
@@ -12168,7 +12152,7 @@
               </a:defRPr>
             </a:pPr>
             <a:r>
-              <a:t>•  Democratize Educational AI: Curate high-impact, 1-click copyable AI study prompts enabling rural students to leverage Gemini and ChatGPT for mathematics, essays, and vernacular explanations.</a:t>
+              <a:t>🏆  Automate Scholarship Discovery: Build a 30-second eligibility checker matching students to Central and State financial schemes with direct application links.</a:t>
             </a:r>
           </a:p>
           <a:p>
@@ -12184,7 +12168,7 @@
               </a:defRPr>
             </a:pPr>
             <a:r>
-              <a:t>•  Cyber Literacy &amp; Scam Prevention: Equip rural first-generation digital users with cyber safety rules, digital readiness self-assessments, and official 1930 cybercrime reporting guidance.</a:t>
+              <a:t>🛡️  Teach Cyber Scam Defense: Equip students with practical digital safety skills, a 30-second readiness quiz, and guidance to detect fake scholarship traps.</a:t>
             </a:r>
           </a:p>
           <a:p>
@@ -12200,7 +12184,7 @@
               </a:defRPr>
             </a:pPr>
             <a:r>
-              <a:t>•  Zero-Barrier Universal Access: Deliver an ultra-lightweight, ad-free web platform that operates smoothly on low-cost smartphones and 3G networks without requiring registration or logins.</a:t>
+              <a:t>🦉  Deliver Bilingual AI Support: Provide Uday the Owl—a bilingual AI assistant powered by Google Gemini and Web Speech voice technology for instant student queries.</a:t>
             </a:r>
           </a:p>
         </p:txBody>
@@ -12673,7 +12657,7 @@
               </a:defRPr>
             </a:pPr>
             <a:r>
-              <a:t>•  Target Audience: Comprehensive coverage tailored specifically for rural 10th (SSC), Intermediate (+2), Diploma/Polytechnic, and ITI students across Andhra Pradesh and Telangana.</a:t>
+              <a:t>🎓  Target Audience: Comprehensive coverage tailored specifically for rural 10th (SSC), Intermediate (+2), Polytechnic, and ITI students.</a:t>
             </a:r>
           </a:p>
           <a:p>
@@ -12689,7 +12673,7 @@
               </a:defRPr>
             </a:pPr>
             <a:r>
-              <a:t>•  Functional Modules: Integrated Career Roadmap Explorer, AP/TS Dual Eligibility Scholarship Matcher, Scheme Comparison Matrix, SCERT Textbook Hub, AI Prompts, and Digital Scam Buster.</a:t>
+              <a:t>🤖  Core Platform Features: 10+ AI Tools Directory, Google Gemini AI Chatbot, Career Stream Explorer, 30-Sec Scholarship Checker, SCERT Books Hub, and Cyber Scam Buster.</a:t>
             </a:r>
           </a:p>
           <a:p>
@@ -12705,7 +12689,7 @@
               </a:defRPr>
             </a:pPr>
             <a:r>
-              <a:t>•  Accessibility &amp; Reach: 100% responsive design optimized for entry-level mobile devices, offline study pack downloads, and bilingual English-Telugu synthesized voice assistance.</a:t>
+              <a:t>📱  Universal Accessibility: 100% mobile-responsive design, offline printable PDF packs, and English-Telugu synthesized voice assistance.</a:t>
             </a:r>
           </a:p>
           <a:p>
@@ -12724,7 +12708,7 @@
               </a:defRPr>
             </a:pPr>
             <a:r>
-              <a:t>Out-of-Scope (Deliberate Design Boundaries)</a:t>
+              <a:t>Out-of-Scope (Deliberate Boundaries)</a:t>
             </a:r>
           </a:p>
           <a:p>
@@ -12740,7 +12724,7 @@
               </a:defRPr>
             </a:pPr>
             <a:r>
-              <a:t>•  Not a Classroom Replacement: Designed strictly as an informational and career guidance bridge, not as a substitute for classroom teachers, curricula, or formal school instruction.</a:t>
+              <a:t>🏫  Not a Classroom Replacement: Designed strictly as an informational and career guidance bridge, not as a substitute for classroom teachers or school syllabi.</a:t>
             </a:r>
           </a:p>
           <a:p>
@@ -12756,7 +12740,7 @@
               </a:defRPr>
             </a:pPr>
             <a:r>
-              <a:t>•  No Direct Financial Transactions: Does not disburse scholarship funds or collect banking credentials; directly redirects students to official government portals (NSP, ePASS).</a:t>
+              <a:t>💳  No Financial Processing: Does not collect banking details or disburse funds; safely redirects students to official government portals (NSP, ePASS).</a:t>
             </a:r>
           </a:p>
           <a:p>
@@ -12772,7 +12756,7 @@
               </a:defRPr>
             </a:pPr>
             <a:r>
-              <a:t>•  Zero Backend Data Harvesting: Operates purely client-side without storing user personal data, phone numbers, or passwords, ensuring complete student privacy.</a:t>
+              <a:t>🔒  Zero Backend Data Tracking: Operates client-side without storing user phone numbers, passwords, or personal records, ensuring complete student privacy.</a:t>
             </a:r>
           </a:p>
         </p:txBody>
@@ -13242,7 +13226,7 @@
               </a:defRPr>
             </a:pPr>
             <a:r>
-              <a:t>•  National Education Policy (NEP 2020) Recommendations: Emphasizes early career mentoring, mother-tongue educational resources, and integration of digital literacy into secondary school stages.</a:t>
+              <a:t>📜  NEP 2020 Recommendations: Highlights the critical importance of early career counselling, mother-tongue educational resources, and foundational AI literacy for school students.</a:t>
             </a:r>
           </a:p>
           <a:p>
@@ -13258,7 +13242,7 @@
               </a:defRPr>
             </a:pPr>
             <a:r>
-              <a:t>•  ASER &amp; Field Research on Rural EdTech: ASER reports indicate that while smartphone access in rural households exceeds 75%, educational use is heavily hindered by English-only interfaces and complex navigation.</a:t>
+              <a:t>📊  ASER Rural Technology Survey: Reports show that while smartphone penetration among rural families exceeds 75%, educational use is crippled by English-only interfaces and complex navigation.</a:t>
             </a:r>
           </a:p>
           <a:p>
@@ -13274,7 +13258,7 @@
               </a:defRPr>
             </a:pPr>
             <a:r>
-              <a:t>•  Evaluation of Official Government Portals: Portals such as NSP and State ePASS provide essential funding but feature fragmented multi-layered user interfaces that require cyber café mediation.</a:t>
+              <a:t>🏛️  Government Portals (NSP &amp; ePASS): Provide essential financial welfare but suffer from multi-layered portals that force rural students to depend on paid cyber café agents.</a:t>
             </a:r>
           </a:p>
           <a:p>
@@ -13290,7 +13274,7 @@
               </a:defRPr>
             </a:pPr>
             <a:r>
-              <a:t>•  Commercial EdTech Platform Barriers: Commercial platforms lock guidance behind paywalls of ₹20,000–₹50,000/year, catering almost exclusively to urban English-medium students.</a:t>
+              <a:t>💸  Commercial EdTech Paywalls: Private guidance and career platforms lock access behind paywalls of ₹20,000–₹50,000/year, catering only to affluent urban learners.</a:t>
             </a:r>
           </a:p>
           <a:p>
@@ -13306,7 +13290,7 @@
               </a:defRPr>
             </a:pPr>
             <a:r>
-              <a:t>•  Synthesis &amp; Need for VidyaUday: Highlights an urgent societal need for a unified, bilingual, lightweight portal offering centralized, free guidance directly to students without intermediaries.</a:t>
+              <a:t>💡  The VidyaUday Bridge: Fills this critical societal gap with a 100% free, lightweight, bilingual portal uniting career guidance, scholarships, AI tools, and digital safety.</a:t>
             </a:r>
           </a:p>
         </p:txBody>
@@ -13888,7 +13872,7 @@
                         </a:defRPr>
                       </a:pPr>
                       <a:r>
-                        <a:t>Access Cost &amp; Subscription</a:t>
+                        <a:t>Access Cost &amp; Ads</a:t>
                       </a:r>
                     </a:p>
                   </a:txBody>
@@ -13912,7 +13896,7 @@
                         </a:defRPr>
                       </a:pPr>
                       <a:r>
-                        <a:t>100% Free Forever</a:t>
+                        <a:t>100% Free / No Ads</a:t>
                       </a:r>
                     </a:p>
                   </a:txBody>
@@ -14010,7 +13994,7 @@
                         </a:defRPr>
                       </a:pPr>
                       <a:r>
-                        <a:t>Language Support</a:t>
+                        <a:t>Curated AI Tools &amp; Prompts</a:t>
                       </a:r>
                     </a:p>
                   </a:txBody>
@@ -14034,7 +14018,7 @@
                         </a:defRPr>
                       </a:pPr>
                       <a:r>
-                        <a:t>English &amp; Telugu (Full)</a:t>
+                        <a:t>Yes (10+ Free Tools)</a:t>
                       </a:r>
                     </a:p>
                   </a:txBody>
@@ -14058,7 +14042,7 @@
                         </a:defRPr>
                       </a:pPr>
                       <a:r>
-                        <a:t>English / Regional Mix</a:t>
+                        <a:t>No AI Tools</a:t>
                       </a:r>
                     </a:p>
                   </a:txBody>
@@ -14082,251 +14066,7 @@
                         </a:defRPr>
                       </a:pPr>
                       <a:r>
-                        <a:t>Predominantly English</a:t>
-                      </a:r>
-                    </a:p>
-                  </a:txBody>
-                  <a:tcPr>
-                    <a:solidFill>
-                      <a:srgbClr val="FFFFFF"/>
-                    </a:solidFill>
-                  </a:tcPr>
-                </a:tc>
-                <a:tc>
-                  <a:txBody>
-                    <a:bodyPr/>
-                    <a:lstStyle/>
-                    <a:p>
-                      <a:pPr algn="ctr">
-                        <a:defRPr sz="1700">
-                          <a:solidFill>
-                            <a:srgbClr val="0F172A"/>
-                          </a:solidFill>
-                          <a:latin typeface="Times New Roman"/>
-                        </a:defRPr>
-                      </a:pPr>
-                      <a:r>
-                        <a:t>Single Language</a:t>
-                      </a:r>
-                    </a:p>
-                  </a:txBody>
-                  <a:tcPr>
-                    <a:solidFill>
-                      <a:srgbClr val="FFFFFF"/>
-                    </a:solidFill>
-                  </a:tcPr>
-                </a:tc>
-              </a:tr>
-              <a:tr h="731520">
-                <a:tc>
-                  <a:txBody>
-                    <a:bodyPr/>
-                    <a:lstStyle/>
-                    <a:p>
-                      <a:pPr algn="l">
-                        <a:defRPr sz="1700">
-                          <a:solidFill>
-                            <a:srgbClr val="0F172A"/>
-                          </a:solidFill>
-                          <a:latin typeface="Times New Roman"/>
-                        </a:defRPr>
-                      </a:pPr>
-                      <a:r>
-                        <a:t>Interactive Career Roadmaps</a:t>
-                      </a:r>
-                    </a:p>
-                  </a:txBody>
-                  <a:tcPr>
-                    <a:solidFill>
-                      <a:srgbClr val="F8FAFC"/>
-                    </a:solidFill>
-                  </a:tcPr>
-                </a:tc>
-                <a:tc>
-                  <a:txBody>
-                    <a:bodyPr/>
-                    <a:lstStyle/>
-                    <a:p>
-                      <a:pPr algn="ctr">
-                        <a:defRPr sz="1700" b="1">
-                          <a:solidFill>
-                            <a:srgbClr val="C2410C"/>
-                          </a:solidFill>
-                          <a:latin typeface="Times New Roman"/>
-                        </a:defRPr>
-                      </a:pPr>
-                      <a:r>
-                        <a:t>Yes (Year-by-Year Paths)</a:t>
-                      </a:r>
-                    </a:p>
-                  </a:txBody>
-                  <a:tcPr>
-                    <a:solidFill>
-                      <a:srgbClr val="F8FAFC"/>
-                    </a:solidFill>
-                  </a:tcPr>
-                </a:tc>
-                <a:tc>
-                  <a:txBody>
-                    <a:bodyPr/>
-                    <a:lstStyle/>
-                    <a:p>
-                      <a:pPr algn="ctr">
-                        <a:defRPr sz="1700">
-                          <a:solidFill>
-                            <a:srgbClr val="0F172A"/>
-                          </a:solidFill>
-                          <a:latin typeface="Times New Roman"/>
-                        </a:defRPr>
-                      </a:pPr>
-                      <a:r>
-                        <a:t>No (Raw Notices)</a:t>
-                      </a:r>
-                    </a:p>
-                  </a:txBody>
-                  <a:tcPr>
-                    <a:solidFill>
-                      <a:srgbClr val="F8FAFC"/>
-                    </a:solidFill>
-                  </a:tcPr>
-                </a:tc>
-                <a:tc>
-                  <a:txBody>
-                    <a:bodyPr/>
-                    <a:lstStyle/>
-                    <a:p>
-                      <a:pPr algn="ctr">
-                        <a:defRPr sz="1700">
-                          <a:solidFill>
-                            <a:srgbClr val="0F172A"/>
-                          </a:solidFill>
-                          <a:latin typeface="Times New Roman"/>
-                        </a:defRPr>
-                      </a:pPr>
-                      <a:r>
-                        <a:t>Yes (Paid Paywall)</a:t>
-                      </a:r>
-                    </a:p>
-                  </a:txBody>
-                  <a:tcPr>
-                    <a:solidFill>
-                      <a:srgbClr val="F8FAFC"/>
-                    </a:solidFill>
-                  </a:tcPr>
-                </a:tc>
-                <a:tc>
-                  <a:txBody>
-                    <a:bodyPr/>
-                    <a:lstStyle/>
-                    <a:p>
-                      <a:pPr algn="ctr">
-                        <a:defRPr sz="1700">
-                          <a:solidFill>
-                            <a:srgbClr val="0F172A"/>
-                          </a:solidFill>
-                          <a:latin typeface="Times New Roman"/>
-                        </a:defRPr>
-                      </a:pPr>
-                      <a:r>
-                        <a:t>Static Lists</a:t>
-                      </a:r>
-                    </a:p>
-                  </a:txBody>
-                  <a:tcPr>
-                    <a:solidFill>
-                      <a:srgbClr val="F8FAFC"/>
-                    </a:solidFill>
-                  </a:tcPr>
-                </a:tc>
-              </a:tr>
-              <a:tr h="731520">
-                <a:tc>
-                  <a:txBody>
-                    <a:bodyPr/>
-                    <a:lstStyle/>
-                    <a:p>
-                      <a:pPr algn="l">
-                        <a:defRPr sz="1700">
-                          <a:solidFill>
-                            <a:srgbClr val="0F172A"/>
-                          </a:solidFill>
-                          <a:latin typeface="Times New Roman"/>
-                        </a:defRPr>
-                      </a:pPr>
-                      <a:r>
-                        <a:t>Dual AP/TS Scholarship Checker</a:t>
-                      </a:r>
-                    </a:p>
-                  </a:txBody>
-                  <a:tcPr>
-                    <a:solidFill>
-                      <a:srgbClr val="FFFFFF"/>
-                    </a:solidFill>
-                  </a:tcPr>
-                </a:tc>
-                <a:tc>
-                  <a:txBody>
-                    <a:bodyPr/>
-                    <a:lstStyle/>
-                    <a:p>
-                      <a:pPr algn="ctr">
-                        <a:defRPr sz="1700" b="1">
-                          <a:solidFill>
-                            <a:srgbClr val="C2410C"/>
-                          </a:solidFill>
-                          <a:latin typeface="Times New Roman"/>
-                        </a:defRPr>
-                      </a:pPr>
-                      <a:r>
-                        <a:t>Yes (30-Sec Quiz &amp; Matrix)</a:t>
-                      </a:r>
-                    </a:p>
-                  </a:txBody>
-                  <a:tcPr>
-                    <a:solidFill>
-                      <a:srgbClr val="FFFFFF"/>
-                    </a:solidFill>
-                  </a:tcPr>
-                </a:tc>
-                <a:tc>
-                  <a:txBody>
-                    <a:bodyPr/>
-                    <a:lstStyle/>
-                    <a:p>
-                      <a:pPr algn="ctr">
-                        <a:defRPr sz="1700">
-                          <a:solidFill>
-                            <a:srgbClr val="0F172A"/>
-                          </a:solidFill>
-                          <a:latin typeface="Times New Roman"/>
-                        </a:defRPr>
-                      </a:pPr>
-                      <a:r>
-                        <a:t>Separate State Logins</a:t>
-                      </a:r>
-                    </a:p>
-                  </a:txBody>
-                  <a:tcPr>
-                    <a:solidFill>
-                      <a:srgbClr val="FFFFFF"/>
-                    </a:solidFill>
-                  </a:tcPr>
-                </a:tc>
-                <a:tc>
-                  <a:txBody>
-                    <a:bodyPr/>
-                    <a:lstStyle/>
-                    <a:p>
-                      <a:pPr algn="ctr">
-                        <a:defRPr sz="1700">
-                          <a:solidFill>
-                            <a:srgbClr val="0F172A"/>
-                          </a:solidFill>
-                          <a:latin typeface="Times New Roman"/>
-                        </a:defRPr>
-                      </a:pPr>
-                      <a:r>
-                        <a:t>No (Commercial Only)</a:t>
+                        <a:t>Paid AI Tutors</a:t>
                       </a:r>
                     </a:p>
                   </a:txBody>
@@ -14376,7 +14116,7 @@
                         </a:defRPr>
                       </a:pPr>
                       <a:r>
-                        <a:t>Curated Student AI Prompts</a:t>
+                        <a:t>Gemini AI Voice Chatbot</a:t>
                       </a:r>
                     </a:p>
                   </a:txBody>
@@ -14400,7 +14140,55 @@
                         </a:defRPr>
                       </a:pPr>
                       <a:r>
-                        <a:t>Yes (1-Click Copy Prompts)</a:t>
+                        <a:t>Yes (Uday the Owl)</a:t>
+                      </a:r>
+                    </a:p>
+                  </a:txBody>
+                  <a:tcPr>
+                    <a:solidFill>
+                      <a:srgbClr val="F8FAFC"/>
+                    </a:solidFill>
+                  </a:tcPr>
+                </a:tc>
+                <a:tc>
+                  <a:txBody>
+                    <a:bodyPr/>
+                    <a:lstStyle/>
+                    <a:p>
+                      <a:pPr algn="ctr">
+                        <a:defRPr sz="1700">
+                          <a:solidFill>
+                            <a:srgbClr val="0F172A"/>
+                          </a:solidFill>
+                          <a:latin typeface="Times New Roman"/>
+                        </a:defRPr>
+                      </a:pPr>
+                      <a:r>
+                        <a:t>No Chatbot</a:t>
+                      </a:r>
+                    </a:p>
+                  </a:txBody>
+                  <a:tcPr>
+                    <a:solidFill>
+                      <a:srgbClr val="F8FAFC"/>
+                    </a:solidFill>
+                  </a:tcPr>
+                </a:tc>
+                <a:tc>
+                  <a:txBody>
+                    <a:bodyPr/>
+                    <a:lstStyle/>
+                    <a:p>
+                      <a:pPr algn="ctr">
+                        <a:defRPr sz="1700">
+                          <a:solidFill>
+                            <a:srgbClr val="0F172A"/>
+                          </a:solidFill>
+                          <a:latin typeface="Times New Roman"/>
+                        </a:defRPr>
+                      </a:pPr>
+                      <a:r>
+                        <a:t>Text-Only Paid Bot</a:t>
                       </a:r>
                     </a:p>
                   </a:txBody>
@@ -14434,6 +14222,56 @@
                     </a:solidFill>
                   </a:tcPr>
                 </a:tc>
+              </a:tr>
+              <a:tr h="731520">
+                <a:tc>
+                  <a:txBody>
+                    <a:bodyPr/>
+                    <a:lstStyle/>
+                    <a:p>
+                      <a:pPr algn="l">
+                        <a:defRPr sz="1700">
+                          <a:solidFill>
+                            <a:srgbClr val="0F172A"/>
+                          </a:solidFill>
+                          <a:latin typeface="Times New Roman"/>
+                        </a:defRPr>
+                      </a:pPr>
+                      <a:r>
+                        <a:t>Interactive Career Roadmaps</a:t>
+                      </a:r>
+                    </a:p>
+                  </a:txBody>
+                  <a:tcPr>
+                    <a:solidFill>
+                      <a:srgbClr val="FFFFFF"/>
+                    </a:solidFill>
+                  </a:tcPr>
+                </a:tc>
+                <a:tc>
+                  <a:txBody>
+                    <a:bodyPr/>
+                    <a:lstStyle/>
+                    <a:p>
+                      <a:pPr algn="ctr">
+                        <a:defRPr sz="1700" b="1">
+                          <a:solidFill>
+                            <a:srgbClr val="C2410C"/>
+                          </a:solidFill>
+                          <a:latin typeface="Times New Roman"/>
+                        </a:defRPr>
+                      </a:pPr>
+                      <a:r>
+                        <a:t>Yes (Year-by-Year Paths)</a:t>
+                      </a:r>
+                    </a:p>
+                  </a:txBody>
+                  <a:tcPr>
+                    <a:solidFill>
+                      <a:srgbClr val="FFFFFF"/>
+                    </a:solidFill>
+                  </a:tcPr>
+                </a:tc>
                 <a:tc>
                   <a:txBody>
                     <a:bodyPr/>
@@ -14448,7 +14286,153 @@
                         </a:defRPr>
                       </a:pPr>
                       <a:r>
-                        <a:t>Paid AI Tutors</a:t>
+                        <a:t>No (Raw Notices)</a:t>
+                      </a:r>
+                    </a:p>
+                  </a:txBody>
+                  <a:tcPr>
+                    <a:solidFill>
+                      <a:srgbClr val="FFFFFF"/>
+                    </a:solidFill>
+                  </a:tcPr>
+                </a:tc>
+                <a:tc>
+                  <a:txBody>
+                    <a:bodyPr/>
+                    <a:lstStyle/>
+                    <a:p>
+                      <a:pPr algn="ctr">
+                        <a:defRPr sz="1700">
+                          <a:solidFill>
+                            <a:srgbClr val="0F172A"/>
+                          </a:solidFill>
+                          <a:latin typeface="Times New Roman"/>
+                        </a:defRPr>
+                      </a:pPr>
+                      <a:r>
+                        <a:t>Yes (Paid Paywall)</a:t>
+                      </a:r>
+                    </a:p>
+                  </a:txBody>
+                  <a:tcPr>
+                    <a:solidFill>
+                      <a:srgbClr val="FFFFFF"/>
+                    </a:solidFill>
+                  </a:tcPr>
+                </a:tc>
+                <a:tc>
+                  <a:txBody>
+                    <a:bodyPr/>
+                    <a:lstStyle/>
+                    <a:p>
+                      <a:pPr algn="ctr">
+                        <a:defRPr sz="1700">
+                          <a:solidFill>
+                            <a:srgbClr val="0F172A"/>
+                          </a:solidFill>
+                          <a:latin typeface="Times New Roman"/>
+                        </a:defRPr>
+                      </a:pPr>
+                      <a:r>
+                        <a:t>Static Lists</a:t>
+                      </a:r>
+                    </a:p>
+                  </a:txBody>
+                  <a:tcPr>
+                    <a:solidFill>
+                      <a:srgbClr val="FFFFFF"/>
+                    </a:solidFill>
+                  </a:tcPr>
+                </a:tc>
+              </a:tr>
+              <a:tr h="731520">
+                <a:tc>
+                  <a:txBody>
+                    <a:bodyPr/>
+                    <a:lstStyle/>
+                    <a:p>
+                      <a:pPr algn="l">
+                        <a:defRPr sz="1700">
+                          <a:solidFill>
+                            <a:srgbClr val="0F172A"/>
+                          </a:solidFill>
+                          <a:latin typeface="Times New Roman"/>
+                        </a:defRPr>
+                      </a:pPr>
+                      <a:r>
+                        <a:t>Dual-State Scholarship Checker</a:t>
+                      </a:r>
+                    </a:p>
+                  </a:txBody>
+                  <a:tcPr>
+                    <a:solidFill>
+                      <a:srgbClr val="F8FAFC"/>
+                    </a:solidFill>
+                  </a:tcPr>
+                </a:tc>
+                <a:tc>
+                  <a:txBody>
+                    <a:bodyPr/>
+                    <a:lstStyle/>
+                    <a:p>
+                      <a:pPr algn="ctr">
+                        <a:defRPr sz="1700" b="1">
+                          <a:solidFill>
+                            <a:srgbClr val="C2410C"/>
+                          </a:solidFill>
+                          <a:latin typeface="Times New Roman"/>
+                        </a:defRPr>
+                      </a:pPr>
+                      <a:r>
+                        <a:t>Yes (30-Sec Quiz &amp; Matrix)</a:t>
+                      </a:r>
+                    </a:p>
+                  </a:txBody>
+                  <a:tcPr>
+                    <a:solidFill>
+                      <a:srgbClr val="F8FAFC"/>
+                    </a:solidFill>
+                  </a:tcPr>
+                </a:tc>
+                <a:tc>
+                  <a:txBody>
+                    <a:bodyPr/>
+                    <a:lstStyle/>
+                    <a:p>
+                      <a:pPr algn="ctr">
+                        <a:defRPr sz="1700">
+                          <a:solidFill>
+                            <a:srgbClr val="0F172A"/>
+                          </a:solidFill>
+                          <a:latin typeface="Times New Roman"/>
+                        </a:defRPr>
+                      </a:pPr>
+                      <a:r>
+                        <a:t>Separate State Logins</a:t>
+                      </a:r>
+                    </a:p>
+                  </a:txBody>
+                  <a:tcPr>
+                    <a:solidFill>
+                      <a:srgbClr val="F8FAFC"/>
+                    </a:solidFill>
+                  </a:tcPr>
+                </a:tc>
+                <a:tc>
+                  <a:txBody>
+                    <a:bodyPr/>
+                    <a:lstStyle/>
+                    <a:p>
+                      <a:pPr algn="ctr">
+                        <a:defRPr sz="1700">
+                          <a:solidFill>
+                            <a:srgbClr val="0F172A"/>
+                          </a:solidFill>
+                          <a:latin typeface="Times New Roman"/>
+                        </a:defRPr>
+                      </a:pPr>
+                      <a:r>
+                        <a:t>No</a:t>
                       </a:r>
                     </a:p>
                   </a:txBody>
@@ -14877,7 +14861,7 @@
               </a:defRPr>
             </a:pPr>
             <a:r>
-              <a:t>Every module is powered by real, verified field and government data</a:t>
+              <a:t>Every module is powered by real, verified field and educational data</a:t>
             </a:r>
           </a:p>
         </p:txBody>
@@ -15061,7 +15045,7 @@
               </a:defRPr>
             </a:pPr>
             <a:r>
-              <a:t>Primary Field Research (MVGR CSP Outreach Survey)</a:t>
+              <a:t>Primary Field Research (Rural Student Outreach Survey)</a:t>
             </a:r>
           </a:p>
           <a:p>
@@ -15077,7 +15061,7 @@
               </a:defRPr>
             </a:pPr>
             <a:r>
-              <a:t>•  Empirical Student Survey: Conducted field surveys and interactive sessions across 120+ rural high school and intermediate students in Vizianagaram district and adjoining mandals.</a:t>
+              <a:t>📋  Field Survey of 120+ Students: Conducted direct interactive surveys with high school and junior college students in rural mandals.</a:t>
             </a:r>
           </a:p>
           <a:p>
@@ -15093,7 +15077,7 @@
               </a:defRPr>
             </a:pPr>
             <a:r>
-              <a:t>•  Career Awareness Findings: 74.2% of surveyed students were unaware of alternative diploma, vocational, or allied health options beyond MPC/BiPC.</a:t>
+              <a:t>❓  Lack of Alternatives: 74.2% of students did not know about polytechnic, ITI, or vocational careers beyond traditional MPC/BiPC.</a:t>
             </a:r>
           </a:p>
           <a:p>
@@ -15109,7 +15093,7 @@
               </a:defRPr>
             </a:pPr>
             <a:r>
-              <a:t>•  Technology Gap: 81.5% of students had never used free AI assistance tools for homework, math problem-solving, or vocabulary enhancement.</a:t>
+              <a:t>🤖  Zero AI Exposure: 81.5% had never used AI study assistants, believing AI is only for software engineers.</a:t>
             </a:r>
           </a:p>
           <a:p>
@@ -15125,7 +15109,7 @@
               </a:defRPr>
             </a:pPr>
             <a:r>
-              <a:t>•  Scholarship Disconnect: 68.4% of eligible students missed statutory financial aid deadlines due to procedural complexity and lack of notification.</a:t>
+              <a:t>💸  Scholarship Information Gap: 68.4% of eligible students missed government financial aid deadlines due to procedural confusion.</a:t>
             </a:r>
           </a:p>
           <a:p>
@@ -15144,7 +15128,7 @@
               </a:defRPr>
             </a:pPr>
             <a:r>
-              <a:t>Secondary Data &amp; Statutory Government Gazette Sources</a:t>
+              <a:t>Secondary Data &amp; Official Sources Curated</a:t>
             </a:r>
           </a:p>
           <a:p>
@@ -15160,7 +15144,7 @@
               </a:defRPr>
             </a:pPr>
             <a:r>
-              <a:t>•  Government Welfare Orders: Formulated scholarship rule engines using official AP Social Welfare Department Gazettes (G.O. Ms. No. 77 &amp; 115) for Jagananna Vidya Deevena &amp; Vasathi Deevena.</a:t>
+              <a:t>🤖  AI Tools &amp; Prompt Library: Curated 10+ free tools (ChatGPT, Gemini, Canva, Gamma, GitHub) with tested student prompt templates.</a:t>
             </a:r>
           </a:p>
           <a:p>
@@ -15176,7 +15160,7 @@
               </a:defRPr>
             </a:pPr>
             <a:r>
-              <a:t>•  State &amp; Central Schemes: Codified eligibility rules from Telangana ePASS (CGG) and National Scholarship Portal (NSP Post-Matric, NMMS, Pragati, Saksham).</a:t>
+              <a:t>🗺️  Career Progression Data: Mapped 11 complete academic streams after 10th and 12th with real-world entry-to-senior salary trends.</a:t>
             </a:r>
           </a:p>
           <a:p>
@@ -15192,7 +15176,23 @@
               </a:defRPr>
             </a:pPr>
             <a:r>
-              <a:t>•  Official Curriculum Data: Mapped authentic digitized textbook repositories from AP SCERT and TS SCERT official academic portals.</a:t>
+              <a:t>🏆  Statutory Welfare Gazettes: Codified official scholarship rules from AP Social Welfare (JVD/JVD), Telangana ePASS, and NSP Central Schemes.</a:t>
+            </a:r>
+          </a:p>
+          <a:p>
+            <a:pPr algn="just">
+              <a:spcAft>
+                <a:spcPts val="400"/>
+              </a:spcAft>
+              <a:defRPr sz="2000">
+                <a:solidFill>
+                  <a:srgbClr val="1E293B"/>
+                </a:solidFill>
+                <a:latin typeface="Times New Roman"/>
+              </a:defRPr>
+            </a:pPr>
+            <a:r>
+              <a:t>📚  Official Curriculum Data: Mapped authentic digitized textbook repositories from official state SCERT and SWAYAM portals.</a:t>
             </a:r>
           </a:p>
         </p:txBody>

</xml_diff>